<commit_message>
Adjusted README with new results. Adjusted cost function and simplified threshold tuning to two-step procedure.
</commit_message>
<xml_diff>
--- a/Picture CV framework.pptx
+++ b/Picture CV framework.pptx
@@ -259,7 +259,7 @@
           <a:p>
             <a:fld id="{3DC2067C-9D5A-4985-9D7F-4C5D317BFC68}" type="datetimeFigureOut">
               <a:rPr lang="de-DE" smtClean="0"/>
-              <a:t>26.10.2026</a:t>
+              <a:t>29.10.2026</a:t>
             </a:fld>
             <a:endParaRPr lang="de-DE"/>
           </a:p>
@@ -457,7 +457,7 @@
           <a:p>
             <a:fld id="{3DC2067C-9D5A-4985-9D7F-4C5D317BFC68}" type="datetimeFigureOut">
               <a:rPr lang="de-DE" smtClean="0"/>
-              <a:t>26.10.2026</a:t>
+              <a:t>29.10.2026</a:t>
             </a:fld>
             <a:endParaRPr lang="de-DE"/>
           </a:p>
@@ -665,7 +665,7 @@
           <a:p>
             <a:fld id="{3DC2067C-9D5A-4985-9D7F-4C5D317BFC68}" type="datetimeFigureOut">
               <a:rPr lang="de-DE" smtClean="0"/>
-              <a:t>26.10.2026</a:t>
+              <a:t>29.10.2026</a:t>
             </a:fld>
             <a:endParaRPr lang="de-DE"/>
           </a:p>
@@ -863,7 +863,7 @@
           <a:p>
             <a:fld id="{3DC2067C-9D5A-4985-9D7F-4C5D317BFC68}" type="datetimeFigureOut">
               <a:rPr lang="de-DE" smtClean="0"/>
-              <a:t>26.10.2026</a:t>
+              <a:t>29.10.2026</a:t>
             </a:fld>
             <a:endParaRPr lang="de-DE"/>
           </a:p>
@@ -1138,7 +1138,7 @@
           <a:p>
             <a:fld id="{3DC2067C-9D5A-4985-9D7F-4C5D317BFC68}" type="datetimeFigureOut">
               <a:rPr lang="de-DE" smtClean="0"/>
-              <a:t>26.10.2026</a:t>
+              <a:t>29.10.2026</a:t>
             </a:fld>
             <a:endParaRPr lang="de-DE"/>
           </a:p>
@@ -1403,7 +1403,7 @@
           <a:p>
             <a:fld id="{3DC2067C-9D5A-4985-9D7F-4C5D317BFC68}" type="datetimeFigureOut">
               <a:rPr lang="de-DE" smtClean="0"/>
-              <a:t>26.10.2026</a:t>
+              <a:t>29.10.2026</a:t>
             </a:fld>
             <a:endParaRPr lang="de-DE"/>
           </a:p>
@@ -1815,7 +1815,7 @@
           <a:p>
             <a:fld id="{3DC2067C-9D5A-4985-9D7F-4C5D317BFC68}" type="datetimeFigureOut">
               <a:rPr lang="de-DE" smtClean="0"/>
-              <a:t>26.10.2026</a:t>
+              <a:t>29.10.2026</a:t>
             </a:fld>
             <a:endParaRPr lang="de-DE"/>
           </a:p>
@@ -1956,7 +1956,7 @@
           <a:p>
             <a:fld id="{3DC2067C-9D5A-4985-9D7F-4C5D317BFC68}" type="datetimeFigureOut">
               <a:rPr lang="de-DE" smtClean="0"/>
-              <a:t>26.10.2026</a:t>
+              <a:t>29.10.2026</a:t>
             </a:fld>
             <a:endParaRPr lang="de-DE"/>
           </a:p>
@@ -2069,7 +2069,7 @@
           <a:p>
             <a:fld id="{3DC2067C-9D5A-4985-9D7F-4C5D317BFC68}" type="datetimeFigureOut">
               <a:rPr lang="de-DE" smtClean="0"/>
-              <a:t>26.10.2026</a:t>
+              <a:t>29.10.2026</a:t>
             </a:fld>
             <a:endParaRPr lang="de-DE"/>
           </a:p>
@@ -2380,7 +2380,7 @@
           <a:p>
             <a:fld id="{3DC2067C-9D5A-4985-9D7F-4C5D317BFC68}" type="datetimeFigureOut">
               <a:rPr lang="de-DE" smtClean="0"/>
-              <a:t>26.10.2026</a:t>
+              <a:t>29.10.2026</a:t>
             </a:fld>
             <a:endParaRPr lang="de-DE"/>
           </a:p>
@@ -2668,7 +2668,7 @@
           <a:p>
             <a:fld id="{3DC2067C-9D5A-4985-9D7F-4C5D317BFC68}" type="datetimeFigureOut">
               <a:rPr lang="de-DE" smtClean="0"/>
-              <a:t>26.10.2026</a:t>
+              <a:t>29.10.2026</a:t>
             </a:fld>
             <a:endParaRPr lang="de-DE"/>
           </a:p>
@@ -2909,7 +2909,7 @@
           <a:p>
             <a:fld id="{3DC2067C-9D5A-4985-9D7F-4C5D317BFC68}" type="datetimeFigureOut">
               <a:rPr lang="de-DE" smtClean="0"/>
-              <a:t>26.10.2026</a:t>
+              <a:t>29.10.2026</a:t>
             </a:fld>
             <a:endParaRPr lang="de-DE"/>
           </a:p>
@@ -3328,10 +3328,10 @@
       </p:grpSpPr>
       <p:grpSp>
         <p:nvGrpSpPr>
-          <p:cNvPr id="3" name="Gruppieren 2">
-            <a:extLst>
-              <a:ext uri="{FF2B5EF4-FFF2-40B4-BE49-F238E27FC236}">
-                <a16:creationId xmlns:a16="http://schemas.microsoft.com/office/drawing/2014/main" id="{BBB3721C-EDD7-57E7-D976-CD88B1D21A56}"/>
+          <p:cNvPr id="45" name="Gruppieren 44">
+            <a:extLst>
+              <a:ext uri="{FF2B5EF4-FFF2-40B4-BE49-F238E27FC236}">
+                <a16:creationId xmlns:a16="http://schemas.microsoft.com/office/drawing/2014/main" id="{90EC3E1C-11B6-E137-85BB-03F89EE7A673}"/>
               </a:ext>
             </a:extLst>
           </p:cNvPr>
@@ -3340,10 +3340,10 @@
         </p:nvGrpSpPr>
         <p:grpSpPr>
           <a:xfrm>
-            <a:off x="301557" y="-28840"/>
-            <a:ext cx="11128443" cy="4114457"/>
-            <a:chOff x="301557" y="-28840"/>
-            <a:chExt cx="11128443" cy="4114457"/>
+            <a:off x="295545" y="0"/>
+            <a:ext cx="11128443" cy="4883285"/>
+            <a:chOff x="295545" y="0"/>
+            <a:chExt cx="11128443" cy="4883285"/>
           </a:xfrm>
         </p:grpSpPr>
         <p:sp>
@@ -3360,8 +3360,8 @@
           </p:nvSpPr>
           <p:spPr>
             <a:xfrm>
-              <a:off x="301557" y="136187"/>
-              <a:ext cx="11128443" cy="3949430"/>
+              <a:off x="295545" y="0"/>
+              <a:ext cx="11128443" cy="4883285"/>
             </a:xfrm>
             <a:prstGeom prst="rect">
               <a:avLst/>
@@ -3400,10 +3400,10 @@
         </p:sp>
         <p:sp>
           <p:nvSpPr>
-            <p:cNvPr id="33" name="Bogen 32">
+            <p:cNvPr id="5" name="Rechteck 4">
               <a:extLst>
                 <a:ext uri="{FF2B5EF4-FFF2-40B4-BE49-F238E27FC236}">
-                  <a16:creationId xmlns:a16="http://schemas.microsoft.com/office/drawing/2014/main" id="{7922F6A1-21E5-4302-600A-0FE9A23C6CD2}"/>
+                  <a16:creationId xmlns:a16="http://schemas.microsoft.com/office/drawing/2014/main" id="{FA2F5DEC-991B-FBBE-C5B1-0B59AAD74843}"/>
                 </a:ext>
               </a:extLst>
             </p:cNvPr>
@@ -3411,33 +3411,41 @@
             <p:nvPr/>
           </p:nvSpPr>
           <p:spPr>
-            <a:xfrm rot="6212833">
-              <a:off x="7881467" y="-742739"/>
-              <a:ext cx="2233136" cy="3660933"/>
+            <a:xfrm>
+              <a:off x="8717141" y="365715"/>
+              <a:ext cx="2451370" cy="514800"/>
             </a:xfrm>
-            <a:prstGeom prst="arc">
-              <a:avLst>
-                <a:gd name="adj1" fmla="val 16200000"/>
-                <a:gd name="adj2" fmla="val 21479892"/>
-              </a:avLst>
+            <a:prstGeom prst="rect">
+              <a:avLst/>
             </a:prstGeom>
-            <a:ln>
-              <a:headEnd type="triangle" w="lg" len="med"/>
-              <a:tailEnd type="none"/>
-            </a:ln>
+            <a:solidFill>
+              <a:schemeClr val="accent2">
+                <a:lumMod val="20000"/>
+                <a:lumOff val="80000"/>
+              </a:schemeClr>
+            </a:solidFill>
+            <a:effectLst>
+              <a:outerShdw blurRad="50800" dist="38100" dir="2700000" algn="tl" rotWithShape="0">
+                <a:prstClr val="black">
+                  <a:alpha val="40000"/>
+                </a:prstClr>
+              </a:outerShdw>
+            </a:effectLst>
           </p:spPr>
           <p:style>
             <a:lnRef idx="2">
-              <a:schemeClr val="dk1"/>
+              <a:schemeClr val="accent1">
+                <a:shade val="15000"/>
+              </a:schemeClr>
             </a:lnRef>
-            <a:fillRef idx="0">
-              <a:schemeClr val="dk1"/>
+            <a:fillRef idx="1">
+              <a:schemeClr val="accent1"/>
             </a:fillRef>
-            <a:effectRef idx="1">
-              <a:schemeClr val="dk1"/>
+            <a:effectRef idx="0">
+              <a:schemeClr val="accent1"/>
             </a:effectRef>
             <a:fontRef idx="minor">
-              <a:schemeClr val="tx1"/>
+              <a:schemeClr val="lt1"/>
             </a:fontRef>
           </p:style>
           <p:txBody>
@@ -3445,16 +3453,23 @@
             <a:lstStyle/>
             <a:p>
               <a:pPr algn="ctr"/>
-              <a:endParaRPr lang="de-DE"/>
+              <a:r>
+                <a:rPr lang="de-DE" dirty="0">
+                  <a:solidFill>
+                    <a:schemeClr val="tx1"/>
+                  </a:solidFill>
+                </a:rPr>
+                <a:t>Test sample (11%)</a:t>
+              </a:r>
             </a:p>
           </p:txBody>
         </p:sp>
         <p:grpSp>
           <p:nvGrpSpPr>
-            <p:cNvPr id="35" name="Gruppieren 34">
+            <p:cNvPr id="7" name="Gruppieren 6">
               <a:extLst>
                 <a:ext uri="{FF2B5EF4-FFF2-40B4-BE49-F238E27FC236}">
-                  <a16:creationId xmlns:a16="http://schemas.microsoft.com/office/drawing/2014/main" id="{E12AA6AE-F7AF-1E60-7DB1-1A303305B854}"/>
+                  <a16:creationId xmlns:a16="http://schemas.microsoft.com/office/drawing/2014/main" id="{6E4EDCDF-75DC-350F-4CCC-FF5C18BB3551}"/>
                 </a:ext>
               </a:extLst>
             </p:cNvPr>
@@ -3463,18 +3478,18 @@
           </p:nvGrpSpPr>
           <p:grpSpPr>
             <a:xfrm>
-              <a:off x="568341" y="365715"/>
-              <a:ext cx="10770304" cy="3455630"/>
-              <a:chOff x="568341" y="365715"/>
-              <a:chExt cx="10770304" cy="3455630"/>
+              <a:off x="573931" y="365715"/>
+              <a:ext cx="8015592" cy="993185"/>
+              <a:chOff x="573931" y="395435"/>
+              <a:chExt cx="7986409" cy="1535508"/>
             </a:xfrm>
           </p:grpSpPr>
           <p:sp>
             <p:nvSpPr>
-              <p:cNvPr id="5" name="Rechteck 4">
+              <p:cNvPr id="4" name="Rechteck 3">
                 <a:extLst>
                   <a:ext uri="{FF2B5EF4-FFF2-40B4-BE49-F238E27FC236}">
-                    <a16:creationId xmlns:a16="http://schemas.microsoft.com/office/drawing/2014/main" id="{FA2F5DEC-991B-FBBE-C5B1-0B59AAD74843}"/>
+                    <a16:creationId xmlns:a16="http://schemas.microsoft.com/office/drawing/2014/main" id="{D58801C8-A738-CA96-5F29-FB87F0555F6A}"/>
                   </a:ext>
                 </a:extLst>
               </p:cNvPr>
@@ -3483,14 +3498,14 @@
             </p:nvSpPr>
             <p:spPr>
               <a:xfrm>
-                <a:off x="8717141" y="365715"/>
-                <a:ext cx="2451370" cy="514800"/>
+                <a:off x="573932" y="395435"/>
+                <a:ext cx="7986407" cy="795903"/>
               </a:xfrm>
               <a:prstGeom prst="rect">
                 <a:avLst/>
               </a:prstGeom>
               <a:solidFill>
-                <a:schemeClr val="accent2">
+                <a:schemeClr val="accent1">
                   <a:lumMod val="20000"/>
                   <a:lumOff val="80000"/>
                 </a:schemeClr>
@@ -3530,533 +3545,17 @@
                       <a:schemeClr val="tx1"/>
                     </a:solidFill>
                   </a:rPr>
-                  <a:t>Test sample (11%)</a:t>
+                  <a:t>Training sample (89%)</a:t>
                 </a:r>
               </a:p>
             </p:txBody>
           </p:sp>
-          <p:grpSp>
-            <p:nvGrpSpPr>
-              <p:cNvPr id="7" name="Gruppieren 6">
+          <p:sp>
+            <p:nvSpPr>
+              <p:cNvPr id="6" name="Geschweifte Klammer rechts 5">
                 <a:extLst>
                   <a:ext uri="{FF2B5EF4-FFF2-40B4-BE49-F238E27FC236}">
-                    <a16:creationId xmlns:a16="http://schemas.microsoft.com/office/drawing/2014/main" id="{6E4EDCDF-75DC-350F-4CCC-FF5C18BB3551}"/>
-                  </a:ext>
-                </a:extLst>
-              </p:cNvPr>
-              <p:cNvGrpSpPr/>
-              <p:nvPr/>
-            </p:nvGrpSpPr>
-            <p:grpSpPr>
-              <a:xfrm>
-                <a:off x="573931" y="365715"/>
-                <a:ext cx="8015592" cy="993185"/>
-                <a:chOff x="573931" y="395435"/>
-                <a:chExt cx="7986409" cy="1535508"/>
-              </a:xfrm>
-            </p:grpSpPr>
-            <p:sp>
-              <p:nvSpPr>
-                <p:cNvPr id="4" name="Rechteck 3">
-                  <a:extLst>
-                    <a:ext uri="{FF2B5EF4-FFF2-40B4-BE49-F238E27FC236}">
-                      <a16:creationId xmlns:a16="http://schemas.microsoft.com/office/drawing/2014/main" id="{D58801C8-A738-CA96-5F29-FB87F0555F6A}"/>
-                    </a:ext>
-                  </a:extLst>
-                </p:cNvPr>
-                <p:cNvSpPr/>
-                <p:nvPr/>
-              </p:nvSpPr>
-              <p:spPr>
-                <a:xfrm>
-                  <a:off x="573932" y="395435"/>
-                  <a:ext cx="7986407" cy="795903"/>
-                </a:xfrm>
-                <a:prstGeom prst="rect">
-                  <a:avLst/>
-                </a:prstGeom>
-                <a:solidFill>
-                  <a:schemeClr val="accent1">
-                    <a:lumMod val="20000"/>
-                    <a:lumOff val="80000"/>
-                  </a:schemeClr>
-                </a:solidFill>
-                <a:effectLst>
-                  <a:outerShdw blurRad="50800" dist="38100" dir="2700000" algn="tl" rotWithShape="0">
-                    <a:prstClr val="black">
-                      <a:alpha val="40000"/>
-                    </a:prstClr>
-                  </a:outerShdw>
-                </a:effectLst>
-              </p:spPr>
-              <p:style>
-                <a:lnRef idx="2">
-                  <a:schemeClr val="accent1">
-                    <a:shade val="15000"/>
-                  </a:schemeClr>
-                </a:lnRef>
-                <a:fillRef idx="1">
-                  <a:schemeClr val="accent1"/>
-                </a:fillRef>
-                <a:effectRef idx="0">
-                  <a:schemeClr val="accent1"/>
-                </a:effectRef>
-                <a:fontRef idx="minor">
-                  <a:schemeClr val="lt1"/>
-                </a:fontRef>
-              </p:style>
-              <p:txBody>
-                <a:bodyPr rtlCol="0" anchor="ctr"/>
-                <a:lstStyle/>
-                <a:p>
-                  <a:pPr algn="ctr"/>
-                  <a:r>
-                    <a:rPr lang="de-DE" dirty="0">
-                      <a:solidFill>
-                        <a:schemeClr val="tx1"/>
-                      </a:solidFill>
-                    </a:rPr>
-                    <a:t>Training sample (89%)</a:t>
-                  </a:r>
-                </a:p>
-              </p:txBody>
-            </p:sp>
-            <p:sp>
-              <p:nvSpPr>
-                <p:cNvPr id="6" name="Geschweifte Klammer rechts 5">
-                  <a:extLst>
-                    <a:ext uri="{FF2B5EF4-FFF2-40B4-BE49-F238E27FC236}">
-                      <a16:creationId xmlns:a16="http://schemas.microsoft.com/office/drawing/2014/main" id="{286F4F78-CB16-F2AD-8596-BAD41B207A5A}"/>
-                    </a:ext>
-                  </a:extLst>
-                </p:cNvPr>
-                <p:cNvSpPr/>
-                <p:nvPr/>
-              </p:nvSpPr>
-              <p:spPr>
-                <a:xfrm rot="5400000">
-                  <a:off x="4268010" y="-2361388"/>
-                  <a:ext cx="598252" cy="7986409"/>
-                </a:xfrm>
-                <a:prstGeom prst="rightBrace">
-                  <a:avLst/>
-                </a:prstGeom>
-                <a:ln>
-                  <a:solidFill>
-                    <a:schemeClr val="tx1"/>
-                  </a:solidFill>
-                </a:ln>
-              </p:spPr>
-              <p:style>
-                <a:lnRef idx="2">
-                  <a:schemeClr val="accent1"/>
-                </a:lnRef>
-                <a:fillRef idx="0">
-                  <a:schemeClr val="accent1"/>
-                </a:fillRef>
-                <a:effectRef idx="1">
-                  <a:schemeClr val="accent1"/>
-                </a:effectRef>
-                <a:fontRef idx="minor">
-                  <a:schemeClr val="tx1"/>
-                </a:fontRef>
-              </p:style>
-              <p:txBody>
-                <a:bodyPr rtlCol="0" anchor="ctr"/>
-                <a:lstStyle/>
-                <a:p>
-                  <a:pPr algn="ctr"/>
-                  <a:endParaRPr lang="de-DE"/>
-                </a:p>
-              </p:txBody>
-            </p:sp>
-          </p:grpSp>
-          <p:sp>
-            <p:nvSpPr>
-              <p:cNvPr id="16" name="Textfeld 15">
-                <a:extLst>
-                  <a:ext uri="{FF2B5EF4-FFF2-40B4-BE49-F238E27FC236}">
-                    <a16:creationId xmlns:a16="http://schemas.microsoft.com/office/drawing/2014/main" id="{E13F93A9-B564-7515-6BDD-11AED4267684}"/>
-                  </a:ext>
-                </a:extLst>
-              </p:cNvPr>
-              <p:cNvSpPr txBox="1"/>
-              <p:nvPr/>
-            </p:nvSpPr>
-            <p:spPr>
-              <a:xfrm>
-                <a:off x="2128777" y="1428112"/>
-                <a:ext cx="4900310" cy="369332"/>
-              </a:xfrm>
-              <a:prstGeom prst="rect">
-                <a:avLst/>
-              </a:prstGeom>
-              <a:noFill/>
-              <a:ln>
-                <a:noFill/>
-              </a:ln>
-            </p:spPr>
-            <p:txBody>
-              <a:bodyPr wrap="square" rtlCol="0">
-                <a:spAutoFit/>
-              </a:bodyPr>
-              <a:lstStyle/>
-              <a:p>
-                <a:pPr algn="ctr"/>
-                <a:r>
-                  <a:rPr lang="de-DE" b="1" dirty="0"/>
-                  <a:t>5-fold CV (</a:t>
-                </a:r>
-                <a:r>
-                  <a:rPr lang="de-DE" b="1" dirty="0" err="1"/>
-                  <a:t>shuffled</a:t>
-                </a:r>
-                <a:r>
-                  <a:rPr lang="de-DE" b="1" dirty="0"/>
-                  <a:t>) for </a:t>
-                </a:r>
-                <a:r>
-                  <a:rPr lang="de-DE" b="1" dirty="0" err="1"/>
-                  <a:t>hyperparameters</a:t>
-                </a:r>
-                <a:endParaRPr lang="de-DE" b="1" dirty="0"/>
-              </a:p>
-            </p:txBody>
-          </p:sp>
-          <p:grpSp>
-            <p:nvGrpSpPr>
-              <p:cNvPr id="22" name="Gruppieren 21">
-                <a:extLst>
-                  <a:ext uri="{FF2B5EF4-FFF2-40B4-BE49-F238E27FC236}">
-                    <a16:creationId xmlns:a16="http://schemas.microsoft.com/office/drawing/2014/main" id="{6BE999FC-7B13-D6BF-C95F-C8E6037CF1F5}"/>
-                  </a:ext>
-                </a:extLst>
-              </p:cNvPr>
-              <p:cNvGrpSpPr/>
-              <p:nvPr/>
-            </p:nvGrpSpPr>
-            <p:grpSpPr>
-              <a:xfrm>
-                <a:off x="573932" y="1866900"/>
-                <a:ext cx="8010000" cy="514350"/>
-                <a:chOff x="573932" y="2514600"/>
-                <a:chExt cx="8010000" cy="914400"/>
-              </a:xfrm>
-              <a:effectLst>
-                <a:outerShdw blurRad="50800" dist="38100" dir="2700000" algn="tl" rotWithShape="0">
-                  <a:prstClr val="black">
-                    <a:alpha val="40000"/>
-                  </a:prstClr>
-                </a:outerShdw>
-              </a:effectLst>
-            </p:grpSpPr>
-            <p:sp>
-              <p:nvSpPr>
-                <p:cNvPr id="17" name="Rechteck 16">
-                  <a:extLst>
-                    <a:ext uri="{FF2B5EF4-FFF2-40B4-BE49-F238E27FC236}">
-                      <a16:creationId xmlns:a16="http://schemas.microsoft.com/office/drawing/2014/main" id="{E0B5B67E-4B0D-8F7A-4656-2EAACF8CA0A4}"/>
-                    </a:ext>
-                  </a:extLst>
-                </p:cNvPr>
-                <p:cNvSpPr/>
-                <p:nvPr/>
-              </p:nvSpPr>
-              <p:spPr>
-                <a:xfrm>
-                  <a:off x="573932" y="2514600"/>
-                  <a:ext cx="1602000" cy="914400"/>
-                </a:xfrm>
-                <a:prstGeom prst="rect">
-                  <a:avLst/>
-                </a:prstGeom>
-                <a:solidFill>
-                  <a:schemeClr val="accent1">
-                    <a:lumMod val="20000"/>
-                    <a:lumOff val="80000"/>
-                  </a:schemeClr>
-                </a:solidFill>
-                <a:effectLst/>
-              </p:spPr>
-              <p:style>
-                <a:lnRef idx="2">
-                  <a:schemeClr val="accent1">
-                    <a:shade val="15000"/>
-                  </a:schemeClr>
-                </a:lnRef>
-                <a:fillRef idx="1">
-                  <a:schemeClr val="accent1"/>
-                </a:fillRef>
-                <a:effectRef idx="0">
-                  <a:schemeClr val="accent1"/>
-                </a:effectRef>
-                <a:fontRef idx="minor">
-                  <a:schemeClr val="lt1"/>
-                </a:fontRef>
-              </p:style>
-              <p:txBody>
-                <a:bodyPr rtlCol="0" anchor="ctr"/>
-                <a:lstStyle/>
-                <a:p>
-                  <a:pPr algn="ctr"/>
-                  <a:r>
-                    <a:rPr lang="de-DE" dirty="0">
-                      <a:solidFill>
-                        <a:schemeClr val="tx1"/>
-                      </a:solidFill>
-                    </a:rPr>
-                    <a:t>Train</a:t>
-                  </a:r>
-                </a:p>
-              </p:txBody>
-            </p:sp>
-            <p:sp>
-              <p:nvSpPr>
-                <p:cNvPr id="18" name="Rechteck 17">
-                  <a:extLst>
-                    <a:ext uri="{FF2B5EF4-FFF2-40B4-BE49-F238E27FC236}">
-                      <a16:creationId xmlns:a16="http://schemas.microsoft.com/office/drawing/2014/main" id="{553AFE44-7BB0-992A-CC0E-8E9277B40C4B}"/>
-                    </a:ext>
-                  </a:extLst>
-                </p:cNvPr>
-                <p:cNvSpPr/>
-                <p:nvPr/>
-              </p:nvSpPr>
-              <p:spPr>
-                <a:xfrm>
-                  <a:off x="2175932" y="2514600"/>
-                  <a:ext cx="1602000" cy="914400"/>
-                </a:xfrm>
-                <a:prstGeom prst="rect">
-                  <a:avLst/>
-                </a:prstGeom>
-                <a:solidFill>
-                  <a:schemeClr val="accent1">
-                    <a:lumMod val="20000"/>
-                    <a:lumOff val="80000"/>
-                  </a:schemeClr>
-                </a:solidFill>
-                <a:effectLst/>
-              </p:spPr>
-              <p:style>
-                <a:lnRef idx="2">
-                  <a:schemeClr val="accent1">
-                    <a:shade val="15000"/>
-                  </a:schemeClr>
-                </a:lnRef>
-                <a:fillRef idx="1">
-                  <a:schemeClr val="accent1"/>
-                </a:fillRef>
-                <a:effectRef idx="0">
-                  <a:schemeClr val="accent1"/>
-                </a:effectRef>
-                <a:fontRef idx="minor">
-                  <a:schemeClr val="lt1"/>
-                </a:fontRef>
-              </p:style>
-              <p:txBody>
-                <a:bodyPr rtlCol="0" anchor="ctr"/>
-                <a:lstStyle/>
-                <a:p>
-                  <a:pPr algn="ctr"/>
-                  <a:r>
-                    <a:rPr lang="de-DE" dirty="0">
-                      <a:solidFill>
-                        <a:schemeClr val="tx1"/>
-                      </a:solidFill>
-                    </a:rPr>
-                    <a:t>Train</a:t>
-                  </a:r>
-                </a:p>
-              </p:txBody>
-            </p:sp>
-            <p:sp>
-              <p:nvSpPr>
-                <p:cNvPr id="19" name="Rechteck 18">
-                  <a:extLst>
-                    <a:ext uri="{FF2B5EF4-FFF2-40B4-BE49-F238E27FC236}">
-                      <a16:creationId xmlns:a16="http://schemas.microsoft.com/office/drawing/2014/main" id="{22B7345A-0DA1-39B6-C993-05BC61536F5D}"/>
-                    </a:ext>
-                  </a:extLst>
-                </p:cNvPr>
-                <p:cNvSpPr/>
-                <p:nvPr/>
-              </p:nvSpPr>
-              <p:spPr>
-                <a:xfrm>
-                  <a:off x="3777932" y="2514600"/>
-                  <a:ext cx="1602000" cy="914400"/>
-                </a:xfrm>
-                <a:prstGeom prst="rect">
-                  <a:avLst/>
-                </a:prstGeom>
-                <a:solidFill>
-                  <a:schemeClr val="accent1">
-                    <a:lumMod val="20000"/>
-                    <a:lumOff val="80000"/>
-                  </a:schemeClr>
-                </a:solidFill>
-                <a:effectLst/>
-              </p:spPr>
-              <p:style>
-                <a:lnRef idx="2">
-                  <a:schemeClr val="accent1">
-                    <a:shade val="15000"/>
-                  </a:schemeClr>
-                </a:lnRef>
-                <a:fillRef idx="1">
-                  <a:schemeClr val="accent1"/>
-                </a:fillRef>
-                <a:effectRef idx="0">
-                  <a:schemeClr val="accent1"/>
-                </a:effectRef>
-                <a:fontRef idx="minor">
-                  <a:schemeClr val="lt1"/>
-                </a:fontRef>
-              </p:style>
-              <p:txBody>
-                <a:bodyPr rtlCol="0" anchor="ctr"/>
-                <a:lstStyle/>
-                <a:p>
-                  <a:pPr algn="ctr"/>
-                  <a:r>
-                    <a:rPr lang="de-DE" dirty="0">
-                      <a:solidFill>
-                        <a:schemeClr val="tx1"/>
-                      </a:solidFill>
-                    </a:rPr>
-                    <a:t>Train</a:t>
-                  </a:r>
-                </a:p>
-              </p:txBody>
-            </p:sp>
-            <p:sp>
-              <p:nvSpPr>
-                <p:cNvPr id="20" name="Rechteck 19">
-                  <a:extLst>
-                    <a:ext uri="{FF2B5EF4-FFF2-40B4-BE49-F238E27FC236}">
-                      <a16:creationId xmlns:a16="http://schemas.microsoft.com/office/drawing/2014/main" id="{99C764E5-E07B-7262-7F5F-AAD093F212BD}"/>
-                    </a:ext>
-                  </a:extLst>
-                </p:cNvPr>
-                <p:cNvSpPr/>
-                <p:nvPr/>
-              </p:nvSpPr>
-              <p:spPr>
-                <a:xfrm>
-                  <a:off x="5379932" y="2514600"/>
-                  <a:ext cx="1602000" cy="914400"/>
-                </a:xfrm>
-                <a:prstGeom prst="rect">
-                  <a:avLst/>
-                </a:prstGeom>
-                <a:solidFill>
-                  <a:schemeClr val="accent1">
-                    <a:lumMod val="20000"/>
-                    <a:lumOff val="80000"/>
-                  </a:schemeClr>
-                </a:solidFill>
-                <a:effectLst/>
-              </p:spPr>
-              <p:style>
-                <a:lnRef idx="2">
-                  <a:schemeClr val="accent1">
-                    <a:shade val="15000"/>
-                  </a:schemeClr>
-                </a:lnRef>
-                <a:fillRef idx="1">
-                  <a:schemeClr val="accent1"/>
-                </a:fillRef>
-                <a:effectRef idx="0">
-                  <a:schemeClr val="accent1"/>
-                </a:effectRef>
-                <a:fontRef idx="minor">
-                  <a:schemeClr val="lt1"/>
-                </a:fontRef>
-              </p:style>
-              <p:txBody>
-                <a:bodyPr rtlCol="0" anchor="ctr"/>
-                <a:lstStyle/>
-                <a:p>
-                  <a:pPr algn="ctr"/>
-                  <a:r>
-                    <a:rPr lang="de-DE" dirty="0">
-                      <a:solidFill>
-                        <a:schemeClr val="tx1"/>
-                      </a:solidFill>
-                    </a:rPr>
-                    <a:t>Train</a:t>
-                  </a:r>
-                </a:p>
-              </p:txBody>
-            </p:sp>
-            <p:sp>
-              <p:nvSpPr>
-                <p:cNvPr id="21" name="Rechteck 20">
-                  <a:extLst>
-                    <a:ext uri="{FF2B5EF4-FFF2-40B4-BE49-F238E27FC236}">
-                      <a16:creationId xmlns:a16="http://schemas.microsoft.com/office/drawing/2014/main" id="{DAF62687-67CE-7200-47D0-C4F807BCAF46}"/>
-                    </a:ext>
-                  </a:extLst>
-                </p:cNvPr>
-                <p:cNvSpPr/>
-                <p:nvPr/>
-              </p:nvSpPr>
-              <p:spPr>
-                <a:xfrm>
-                  <a:off x="6981932" y="2514600"/>
-                  <a:ext cx="1602000" cy="914400"/>
-                </a:xfrm>
-                <a:prstGeom prst="rect">
-                  <a:avLst/>
-                </a:prstGeom>
-                <a:solidFill>
-                  <a:schemeClr val="accent2">
-                    <a:lumMod val="20000"/>
-                    <a:lumOff val="80000"/>
-                  </a:schemeClr>
-                </a:solidFill>
-                <a:effectLst/>
-              </p:spPr>
-              <p:style>
-                <a:lnRef idx="2">
-                  <a:schemeClr val="accent1">
-                    <a:shade val="15000"/>
-                  </a:schemeClr>
-                </a:lnRef>
-                <a:fillRef idx="1">
-                  <a:schemeClr val="accent1"/>
-                </a:fillRef>
-                <a:effectRef idx="0">
-                  <a:schemeClr val="accent1"/>
-                </a:effectRef>
-                <a:fontRef idx="minor">
-                  <a:schemeClr val="lt1"/>
-                </a:fontRef>
-              </p:style>
-              <p:txBody>
-                <a:bodyPr rtlCol="0" anchor="ctr"/>
-                <a:lstStyle/>
-                <a:p>
-                  <a:pPr algn="ctr"/>
-                  <a:r>
-                    <a:rPr lang="de-DE" dirty="0">
-                      <a:solidFill>
-                        <a:schemeClr val="tx1"/>
-                      </a:solidFill>
-                    </a:rPr>
-                    <a:t>Validation</a:t>
-                  </a:r>
-                </a:p>
-              </p:txBody>
-            </p:sp>
-          </p:grpSp>
-          <p:sp>
-            <p:nvSpPr>
-              <p:cNvPr id="24" name="Geschweifte Klammer rechts 23">
-                <a:extLst>
-                  <a:ext uri="{FF2B5EF4-FFF2-40B4-BE49-F238E27FC236}">
-                    <a16:creationId xmlns:a16="http://schemas.microsoft.com/office/drawing/2014/main" id="{41EDAECF-8B0A-570E-2AC1-8161092DB0FD}"/>
+                    <a16:creationId xmlns:a16="http://schemas.microsoft.com/office/drawing/2014/main" id="{286F4F78-CB16-F2AD-8596-BAD41B207A5A}"/>
                   </a:ext>
                 </a:extLst>
               </p:cNvPr>
@@ -4065,8 +3564,8 @@
             </p:nvSpPr>
             <p:spPr>
               <a:xfrm rot="5400000">
-                <a:off x="3581658" y="-565784"/>
-                <a:ext cx="386957" cy="6413591"/>
+                <a:off x="4268010" y="-2361388"/>
+                <a:ext cx="598252" cy="7986409"/>
               </a:xfrm>
               <a:prstGeom prst="rightBrace">
                 <a:avLst/>
@@ -4100,277 +3599,220 @@
               </a:p>
             </p:txBody>
           </p:sp>
+        </p:grpSp>
+        <p:sp>
+          <p:nvSpPr>
+            <p:cNvPr id="16" name="Textfeld 15">
+              <a:extLst>
+                <a:ext uri="{FF2B5EF4-FFF2-40B4-BE49-F238E27FC236}">
+                  <a16:creationId xmlns:a16="http://schemas.microsoft.com/office/drawing/2014/main" id="{E13F93A9-B564-7515-6BDD-11AED4267684}"/>
+                </a:ext>
+              </a:extLst>
+            </p:cNvPr>
+            <p:cNvSpPr txBox="1"/>
+            <p:nvPr/>
+          </p:nvSpPr>
+          <p:spPr>
+            <a:xfrm>
+              <a:off x="1087075" y="1435605"/>
+              <a:ext cx="6983713" cy="369332"/>
+            </a:xfrm>
+            <a:prstGeom prst="rect">
+              <a:avLst/>
+            </a:prstGeom>
+            <a:noFill/>
+            <a:ln>
+              <a:noFill/>
+            </a:ln>
+          </p:spPr>
+          <p:txBody>
+            <a:bodyPr wrap="square" rtlCol="0">
+              <a:spAutoFit/>
+            </a:bodyPr>
+            <a:lstStyle/>
+            <a:p>
+              <a:pPr algn="ctr"/>
+              <a:r>
+                <a:rPr lang="de-DE" b="1" dirty="0"/>
+                <a:t>3-fold CV (</a:t>
+              </a:r>
+              <a:r>
+                <a:rPr lang="de-DE" b="1" dirty="0" err="1"/>
+                <a:t>shuffled</a:t>
+              </a:r>
+              <a:r>
+                <a:rPr lang="de-DE" b="1" dirty="0"/>
+                <a:t>) for </a:t>
+              </a:r>
+              <a:r>
+                <a:rPr lang="de-DE" b="1" dirty="0" err="1"/>
+                <a:t>hyperparameters</a:t>
+              </a:r>
+              <a:r>
+                <a:rPr lang="de-DE" b="1" dirty="0"/>
+                <a:t> following ROC-AUC</a:t>
+              </a:r>
+            </a:p>
+          </p:txBody>
+        </p:sp>
+        <p:sp>
+          <p:nvSpPr>
+            <p:cNvPr id="24" name="Geschweifte Klammer rechts 23">
+              <a:extLst>
+                <a:ext uri="{FF2B5EF4-FFF2-40B4-BE49-F238E27FC236}">
+                  <a16:creationId xmlns:a16="http://schemas.microsoft.com/office/drawing/2014/main" id="{41EDAECF-8B0A-570E-2AC1-8161092DB0FD}"/>
+                </a:ext>
+              </a:extLst>
+            </p:cNvPr>
+            <p:cNvSpPr/>
+            <p:nvPr/>
+          </p:nvSpPr>
+          <p:spPr>
+            <a:xfrm rot="5400000">
+              <a:off x="4382656" y="-1366783"/>
+              <a:ext cx="386957" cy="8015589"/>
+            </a:xfrm>
+            <a:prstGeom prst="rightBrace">
+              <a:avLst/>
+            </a:prstGeom>
+            <a:ln>
+              <a:solidFill>
+                <a:schemeClr val="tx1"/>
+              </a:solidFill>
+            </a:ln>
+          </p:spPr>
+          <p:style>
+            <a:lnRef idx="2">
+              <a:schemeClr val="accent1"/>
+            </a:lnRef>
+            <a:fillRef idx="0">
+              <a:schemeClr val="accent1"/>
+            </a:fillRef>
+            <a:effectRef idx="1">
+              <a:schemeClr val="accent1"/>
+            </a:effectRef>
+            <a:fontRef idx="minor">
+              <a:schemeClr val="tx1"/>
+            </a:fontRef>
+          </p:style>
+          <p:txBody>
+            <a:bodyPr rtlCol="0" anchor="ctr"/>
+            <a:lstStyle/>
+            <a:p>
+              <a:pPr algn="ctr"/>
+              <a:endParaRPr lang="de-DE"/>
+            </a:p>
+          </p:txBody>
+        </p:sp>
+        <p:sp>
+          <p:nvSpPr>
+            <p:cNvPr id="25" name="Textfeld 24">
+              <a:extLst>
+                <a:ext uri="{FF2B5EF4-FFF2-40B4-BE49-F238E27FC236}">
+                  <a16:creationId xmlns:a16="http://schemas.microsoft.com/office/drawing/2014/main" id="{CD0D01B8-150E-A3CF-F31B-A886C0380A72}"/>
+                </a:ext>
+              </a:extLst>
+            </p:cNvPr>
+            <p:cNvSpPr txBox="1"/>
+            <p:nvPr/>
+          </p:nvSpPr>
+          <p:spPr>
+            <a:xfrm>
+              <a:off x="742164" y="2874508"/>
+              <a:ext cx="7667939" cy="369332"/>
+            </a:xfrm>
+            <a:prstGeom prst="rect">
+              <a:avLst/>
+            </a:prstGeom>
+            <a:noFill/>
+            <a:ln>
+              <a:noFill/>
+            </a:ln>
+          </p:spPr>
+          <p:txBody>
+            <a:bodyPr wrap="square" rtlCol="0">
+              <a:spAutoFit/>
+            </a:bodyPr>
+            <a:lstStyle/>
+            <a:p>
+              <a:pPr algn="ctr"/>
+              <a:r>
+                <a:rPr lang="de-DE" b="1" dirty="0"/>
+                <a:t>3-fold CV (</a:t>
+              </a:r>
+              <a:r>
+                <a:rPr lang="de-DE" b="1" dirty="0" err="1"/>
+                <a:t>shuffled</a:t>
+              </a:r>
+              <a:r>
+                <a:rPr lang="de-DE" b="1" dirty="0"/>
+                <a:t>) for </a:t>
+              </a:r>
+              <a:r>
+                <a:rPr lang="de-DE" b="1" dirty="0" err="1"/>
+                <a:t>probability</a:t>
+              </a:r>
+              <a:r>
+                <a:rPr lang="de-DE" b="1" dirty="0"/>
+                <a:t> </a:t>
+              </a:r>
+              <a:r>
+                <a:rPr lang="de-DE" b="1" dirty="0" err="1"/>
+                <a:t>threshold</a:t>
+              </a:r>
+              <a:r>
+                <a:rPr lang="de-DE" b="1" dirty="0"/>
+                <a:t> using </a:t>
+              </a:r>
+              <a:r>
+                <a:rPr lang="de-DE" b="1" dirty="0" err="1"/>
+                <a:t>custom</a:t>
+              </a:r>
+              <a:r>
+                <a:rPr lang="de-DE" b="1" dirty="0"/>
+                <a:t> </a:t>
+              </a:r>
+              <a:r>
+                <a:rPr lang="de-DE" b="1" dirty="0" err="1"/>
+                <a:t>scorer</a:t>
+              </a:r>
+              <a:endParaRPr lang="de-DE" b="1" dirty="0"/>
+            </a:p>
+          </p:txBody>
+        </p:sp>
+        <p:grpSp>
+          <p:nvGrpSpPr>
+            <p:cNvPr id="29" name="Gruppieren 28">
+              <a:extLst>
+                <a:ext uri="{FF2B5EF4-FFF2-40B4-BE49-F238E27FC236}">
+                  <a16:creationId xmlns:a16="http://schemas.microsoft.com/office/drawing/2014/main" id="{7C21032B-FEE5-032A-8C1A-A49ABCE5D4E7}"/>
+                </a:ext>
+              </a:extLst>
+            </p:cNvPr>
+            <p:cNvGrpSpPr/>
+            <p:nvPr/>
+          </p:nvGrpSpPr>
+          <p:grpSpPr>
+            <a:xfrm>
+              <a:off x="568340" y="1853727"/>
+              <a:ext cx="8015588" cy="514350"/>
+              <a:chOff x="568341" y="3306995"/>
+              <a:chExt cx="6400528" cy="514350"/>
+            </a:xfrm>
+            <a:effectLst>
+              <a:outerShdw blurRad="50800" dist="38100" dir="2700000" algn="tl" rotWithShape="0">
+                <a:prstClr val="black">
+                  <a:alpha val="40000"/>
+                </a:prstClr>
+              </a:outerShdw>
+            </a:effectLst>
+          </p:grpSpPr>
           <p:sp>
             <p:nvSpPr>
-              <p:cNvPr id="25" name="Textfeld 24">
+              <p:cNvPr id="26" name="Rechteck 25">
                 <a:extLst>
                   <a:ext uri="{FF2B5EF4-FFF2-40B4-BE49-F238E27FC236}">
-                    <a16:creationId xmlns:a16="http://schemas.microsoft.com/office/drawing/2014/main" id="{CD0D01B8-150E-A3CF-F31B-A886C0380A72}"/>
-                  </a:ext>
-                </a:extLst>
-              </p:cNvPr>
-              <p:cNvSpPr txBox="1"/>
-              <p:nvPr/>
-            </p:nvSpPr>
-            <p:spPr>
-              <a:xfrm>
-                <a:off x="1213414" y="2886077"/>
-                <a:ext cx="5123444" cy="369332"/>
-              </a:xfrm>
-              <a:prstGeom prst="rect">
-                <a:avLst/>
-              </a:prstGeom>
-              <a:noFill/>
-              <a:ln>
-                <a:noFill/>
-              </a:ln>
-            </p:spPr>
-            <p:txBody>
-              <a:bodyPr wrap="square" rtlCol="0">
-                <a:spAutoFit/>
-              </a:bodyPr>
-              <a:lstStyle/>
-              <a:p>
-                <a:pPr algn="ctr"/>
-                <a:r>
-                  <a:rPr lang="de-DE" b="1" dirty="0"/>
-                  <a:t>3-fold CV (</a:t>
-                </a:r>
-                <a:r>
-                  <a:rPr lang="de-DE" b="1" dirty="0" err="1"/>
-                  <a:t>shuffled</a:t>
-                </a:r>
-                <a:r>
-                  <a:rPr lang="de-DE" b="1" dirty="0"/>
-                  <a:t>) for </a:t>
-                </a:r>
-                <a:r>
-                  <a:rPr lang="de-DE" b="1" dirty="0" err="1"/>
-                  <a:t>probability</a:t>
-                </a:r>
-                <a:r>
-                  <a:rPr lang="de-DE" b="1" dirty="0"/>
-                  <a:t> </a:t>
-                </a:r>
-                <a:r>
-                  <a:rPr lang="de-DE" b="1" dirty="0" err="1"/>
-                  <a:t>threshold</a:t>
-                </a:r>
-                <a:endParaRPr lang="de-DE" b="1" dirty="0"/>
-              </a:p>
-            </p:txBody>
-          </p:sp>
-          <p:grpSp>
-            <p:nvGrpSpPr>
-              <p:cNvPr id="29" name="Gruppieren 28">
-                <a:extLst>
-                  <a:ext uri="{FF2B5EF4-FFF2-40B4-BE49-F238E27FC236}">
-                    <a16:creationId xmlns:a16="http://schemas.microsoft.com/office/drawing/2014/main" id="{7C21032B-FEE5-032A-8C1A-A49ABCE5D4E7}"/>
-                  </a:ext>
-                </a:extLst>
-              </p:cNvPr>
-              <p:cNvGrpSpPr/>
-              <p:nvPr/>
-            </p:nvGrpSpPr>
-            <p:grpSpPr>
-              <a:xfrm>
-                <a:off x="568341" y="3306995"/>
-                <a:ext cx="6400528" cy="514350"/>
-                <a:chOff x="568341" y="3306995"/>
-                <a:chExt cx="6400528" cy="514350"/>
-              </a:xfrm>
-              <a:effectLst>
-                <a:outerShdw blurRad="50800" dist="38100" dir="2700000" algn="tl" rotWithShape="0">
-                  <a:prstClr val="black">
-                    <a:alpha val="40000"/>
-                  </a:prstClr>
-                </a:outerShdw>
-              </a:effectLst>
-            </p:grpSpPr>
-            <p:sp>
-              <p:nvSpPr>
-                <p:cNvPr id="26" name="Rechteck 25">
-                  <a:extLst>
-                    <a:ext uri="{FF2B5EF4-FFF2-40B4-BE49-F238E27FC236}">
-                      <a16:creationId xmlns:a16="http://schemas.microsoft.com/office/drawing/2014/main" id="{C95A54B9-76B3-6F28-51A1-17ECD31531CE}"/>
-                    </a:ext>
-                  </a:extLst>
-                </p:cNvPr>
-                <p:cNvSpPr/>
-                <p:nvPr/>
-              </p:nvSpPr>
-              <p:spPr>
-                <a:xfrm>
-                  <a:off x="568341" y="3306995"/>
-                  <a:ext cx="2134800" cy="514350"/>
-                </a:xfrm>
-                <a:prstGeom prst="rect">
-                  <a:avLst/>
-                </a:prstGeom>
-                <a:solidFill>
-                  <a:schemeClr val="accent1">
-                    <a:lumMod val="20000"/>
-                    <a:lumOff val="80000"/>
-                  </a:schemeClr>
-                </a:solidFill>
-              </p:spPr>
-              <p:style>
-                <a:lnRef idx="2">
-                  <a:schemeClr val="accent1">
-                    <a:shade val="15000"/>
-                  </a:schemeClr>
-                </a:lnRef>
-                <a:fillRef idx="1">
-                  <a:schemeClr val="accent1"/>
-                </a:fillRef>
-                <a:effectRef idx="0">
-                  <a:schemeClr val="accent1"/>
-                </a:effectRef>
-                <a:fontRef idx="minor">
-                  <a:schemeClr val="lt1"/>
-                </a:fontRef>
-              </p:style>
-              <p:txBody>
-                <a:bodyPr rtlCol="0" anchor="ctr"/>
-                <a:lstStyle/>
-                <a:p>
-                  <a:pPr algn="ctr"/>
-                  <a:r>
-                    <a:rPr lang="de-DE" dirty="0">
-                      <a:solidFill>
-                        <a:schemeClr val="tx1"/>
-                      </a:solidFill>
-                    </a:rPr>
-                    <a:t>Train</a:t>
-                  </a:r>
-                </a:p>
-              </p:txBody>
-            </p:sp>
-            <p:sp>
-              <p:nvSpPr>
-                <p:cNvPr id="27" name="Rechteck 26">
-                  <a:extLst>
-                    <a:ext uri="{FF2B5EF4-FFF2-40B4-BE49-F238E27FC236}">
-                      <a16:creationId xmlns:a16="http://schemas.microsoft.com/office/drawing/2014/main" id="{BA436F26-D697-4329-F0DF-31477506AD5F}"/>
-                    </a:ext>
-                  </a:extLst>
-                </p:cNvPr>
-                <p:cNvSpPr/>
-                <p:nvPr/>
-              </p:nvSpPr>
-              <p:spPr>
-                <a:xfrm>
-                  <a:off x="2699269" y="3306995"/>
-                  <a:ext cx="2134800" cy="514350"/>
-                </a:xfrm>
-                <a:prstGeom prst="rect">
-                  <a:avLst/>
-                </a:prstGeom>
-                <a:solidFill>
-                  <a:schemeClr val="accent1">
-                    <a:lumMod val="20000"/>
-                    <a:lumOff val="80000"/>
-                  </a:schemeClr>
-                </a:solidFill>
-              </p:spPr>
-              <p:style>
-                <a:lnRef idx="2">
-                  <a:schemeClr val="accent1">
-                    <a:shade val="15000"/>
-                  </a:schemeClr>
-                </a:lnRef>
-                <a:fillRef idx="1">
-                  <a:schemeClr val="accent1"/>
-                </a:fillRef>
-                <a:effectRef idx="0">
-                  <a:schemeClr val="accent1"/>
-                </a:effectRef>
-                <a:fontRef idx="minor">
-                  <a:schemeClr val="lt1"/>
-                </a:fontRef>
-              </p:style>
-              <p:txBody>
-                <a:bodyPr rtlCol="0" anchor="ctr"/>
-                <a:lstStyle/>
-                <a:p>
-                  <a:pPr algn="ctr"/>
-                  <a:r>
-                    <a:rPr lang="de-DE" dirty="0">
-                      <a:solidFill>
-                        <a:schemeClr val="tx1"/>
-                      </a:solidFill>
-                    </a:rPr>
-                    <a:t>Train</a:t>
-                  </a:r>
-                </a:p>
-              </p:txBody>
-            </p:sp>
-            <p:sp>
-              <p:nvSpPr>
-                <p:cNvPr id="28" name="Rechteck 27">
-                  <a:extLst>
-                    <a:ext uri="{FF2B5EF4-FFF2-40B4-BE49-F238E27FC236}">
-                      <a16:creationId xmlns:a16="http://schemas.microsoft.com/office/drawing/2014/main" id="{598FAB74-421E-F617-D06B-6D5B9FFC4FB7}"/>
-                    </a:ext>
-                  </a:extLst>
-                </p:cNvPr>
-                <p:cNvSpPr/>
-                <p:nvPr/>
-              </p:nvSpPr>
-              <p:spPr>
-                <a:xfrm>
-                  <a:off x="4834069" y="3306995"/>
-                  <a:ext cx="2134800" cy="514350"/>
-                </a:xfrm>
-                <a:prstGeom prst="rect">
-                  <a:avLst/>
-                </a:prstGeom>
-                <a:solidFill>
-                  <a:schemeClr val="accent2">
-                    <a:lumMod val="20000"/>
-                    <a:lumOff val="80000"/>
-                  </a:schemeClr>
-                </a:solidFill>
-              </p:spPr>
-              <p:style>
-                <a:lnRef idx="2">
-                  <a:schemeClr val="accent1">
-                    <a:shade val="15000"/>
-                  </a:schemeClr>
-                </a:lnRef>
-                <a:fillRef idx="1">
-                  <a:schemeClr val="accent1"/>
-                </a:fillRef>
-                <a:effectRef idx="0">
-                  <a:schemeClr val="accent1"/>
-                </a:effectRef>
-                <a:fontRef idx="minor">
-                  <a:schemeClr val="lt1"/>
-                </a:fontRef>
-              </p:style>
-              <p:txBody>
-                <a:bodyPr rtlCol="0" anchor="ctr"/>
-                <a:lstStyle/>
-                <a:p>
-                  <a:pPr algn="ctr"/>
-                  <a:r>
-                    <a:rPr lang="de-DE" dirty="0">
-                      <a:solidFill>
-                        <a:schemeClr val="tx1"/>
-                      </a:solidFill>
-                    </a:rPr>
-                    <a:t>Validation</a:t>
-                  </a:r>
-                </a:p>
-              </p:txBody>
-            </p:sp>
-          </p:grpSp>
-          <p:sp>
-            <p:nvSpPr>
-              <p:cNvPr id="31" name="Bogen 30">
-                <a:extLst>
-                  <a:ext uri="{FF2B5EF4-FFF2-40B4-BE49-F238E27FC236}">
-                    <a16:creationId xmlns:a16="http://schemas.microsoft.com/office/drawing/2014/main" id="{B7DB6530-7C54-EE33-772B-72E03AD02C5C}"/>
+                    <a16:creationId xmlns:a16="http://schemas.microsoft.com/office/drawing/2014/main" id="{C95A54B9-76B3-6F28-51A1-17ECD31531CE}"/>
                   </a:ext>
                 </a:extLst>
               </p:cNvPr>
@@ -4378,33 +3820,34 @@
               <p:nvPr/>
             </p:nvSpPr>
             <p:spPr>
-              <a:xfrm rot="6212833">
-                <a:off x="6248888" y="655759"/>
-                <a:ext cx="2233136" cy="3660933"/>
+              <a:xfrm>
+                <a:off x="568341" y="3306995"/>
+                <a:ext cx="2134800" cy="514350"/>
               </a:xfrm>
-              <a:prstGeom prst="arc">
-                <a:avLst>
-                  <a:gd name="adj1" fmla="val 16200000"/>
-                  <a:gd name="adj2" fmla="val 21479892"/>
-                </a:avLst>
+              <a:prstGeom prst="rect">
+                <a:avLst/>
               </a:prstGeom>
-              <a:ln>
-                <a:headEnd type="triangle" w="lg" len="med"/>
-                <a:tailEnd type="none"/>
-              </a:ln>
+              <a:solidFill>
+                <a:schemeClr val="accent1">
+                  <a:lumMod val="20000"/>
+                  <a:lumOff val="80000"/>
+                </a:schemeClr>
+              </a:solidFill>
             </p:spPr>
             <p:style>
               <a:lnRef idx="2">
-                <a:schemeClr val="dk1"/>
+                <a:schemeClr val="accent1">
+                  <a:shade val="15000"/>
+                </a:schemeClr>
               </a:lnRef>
-              <a:fillRef idx="0">
-                <a:schemeClr val="dk1"/>
+              <a:fillRef idx="1">
+                <a:schemeClr val="accent1"/>
               </a:fillRef>
-              <a:effectRef idx="1">
-                <a:schemeClr val="dk1"/>
+              <a:effectRef idx="0">
+                <a:schemeClr val="accent1"/>
               </a:effectRef>
               <a:fontRef idx="minor">
-                <a:schemeClr val="tx1"/>
+                <a:schemeClr val="lt1"/>
               </a:fontRef>
             </p:style>
             <p:txBody>
@@ -4412,147 +3855,614 @@
               <a:lstStyle/>
               <a:p>
                 <a:pPr algn="ctr"/>
-                <a:endParaRPr lang="de-DE"/>
+                <a:r>
+                  <a:rPr lang="de-DE" dirty="0">
+                    <a:solidFill>
+                      <a:schemeClr val="tx1"/>
+                    </a:solidFill>
+                  </a:rPr>
+                  <a:t>Train</a:t>
+                </a:r>
               </a:p>
             </p:txBody>
           </p:sp>
           <p:sp>
             <p:nvSpPr>
-              <p:cNvPr id="32" name="Textfeld 31">
+              <p:cNvPr id="27" name="Rechteck 26">
                 <a:extLst>
                   <a:ext uri="{FF2B5EF4-FFF2-40B4-BE49-F238E27FC236}">
-                    <a16:creationId xmlns:a16="http://schemas.microsoft.com/office/drawing/2014/main" id="{1A322C87-3351-18A3-7F35-22AB14F74313}"/>
+                    <a16:creationId xmlns:a16="http://schemas.microsoft.com/office/drawing/2014/main" id="{BA436F26-D697-4329-F0DF-31477506AD5F}"/>
                   </a:ext>
                 </a:extLst>
               </p:cNvPr>
-              <p:cNvSpPr txBox="1"/>
+              <p:cNvSpPr/>
               <p:nvPr/>
             </p:nvSpPr>
             <p:spPr>
               <a:xfrm>
-                <a:off x="6956944" y="2809133"/>
-                <a:ext cx="2134800" cy="523220"/>
+                <a:off x="2699269" y="3306995"/>
+                <a:ext cx="2134800" cy="514350"/>
               </a:xfrm>
               <a:prstGeom prst="rect">
                 <a:avLst/>
               </a:prstGeom>
-              <a:noFill/>
+              <a:solidFill>
+                <a:schemeClr val="accent1">
+                  <a:lumMod val="20000"/>
+                  <a:lumOff val="80000"/>
+                </a:schemeClr>
+              </a:solidFill>
             </p:spPr>
+            <p:style>
+              <a:lnRef idx="2">
+                <a:schemeClr val="accent1">
+                  <a:shade val="15000"/>
+                </a:schemeClr>
+              </a:lnRef>
+              <a:fillRef idx="1">
+                <a:schemeClr val="accent1"/>
+              </a:fillRef>
+              <a:effectRef idx="0">
+                <a:schemeClr val="accent1"/>
+              </a:effectRef>
+              <a:fontRef idx="minor">
+                <a:schemeClr val="lt1"/>
+              </a:fontRef>
+            </p:style>
             <p:txBody>
-              <a:bodyPr wrap="square" rtlCol="0">
-                <a:spAutoFit/>
-              </a:bodyPr>
+              <a:bodyPr rtlCol="0" anchor="ctr"/>
               <a:lstStyle/>
               <a:p>
+                <a:pPr algn="ctr"/>
                 <a:r>
-                  <a:rPr lang="de-DE" sz="1400" dirty="0"/>
-                  <a:t>Pass </a:t>
+                  <a:rPr lang="de-DE" dirty="0">
+                    <a:solidFill>
+                      <a:schemeClr val="tx1"/>
+                    </a:solidFill>
+                  </a:rPr>
+                  <a:t>Train</a:t>
                 </a:r>
-                <a:r>
-                  <a:rPr lang="de-DE" sz="1400" dirty="0" err="1"/>
-                  <a:t>identified</a:t>
-                </a:r>
-                <a:r>
-                  <a:rPr lang="de-DE" sz="1400" dirty="0"/>
-                  <a:t> </a:t>
-                </a:r>
-                <a:r>
-                  <a:rPr lang="de-DE" sz="1400" dirty="0" err="1"/>
-                  <a:t>threshold</a:t>
-                </a:r>
-                <a:r>
-                  <a:rPr lang="de-DE" sz="1400" dirty="0"/>
-                  <a:t> to 5-fold CV </a:t>
-                </a:r>
-                <a:r>
-                  <a:rPr lang="de-DE" sz="1400" dirty="0" err="1"/>
-                  <a:t>training</a:t>
-                </a:r>
-                <a:r>
-                  <a:rPr lang="de-DE" sz="1400" dirty="0"/>
-                  <a:t> </a:t>
-                </a:r>
-                <a:r>
-                  <a:rPr lang="de-DE" sz="1400" dirty="0" err="1"/>
-                  <a:t>data</a:t>
-                </a:r>
-                <a:endParaRPr lang="de-DE" sz="1400" dirty="0"/>
               </a:p>
             </p:txBody>
           </p:sp>
           <p:sp>
             <p:nvSpPr>
-              <p:cNvPr id="34" name="Textfeld 33">
+              <p:cNvPr id="28" name="Rechteck 27">
                 <a:extLst>
                   <a:ext uri="{FF2B5EF4-FFF2-40B4-BE49-F238E27FC236}">
-                    <a16:creationId xmlns:a16="http://schemas.microsoft.com/office/drawing/2014/main" id="{DA318D28-C1BA-850F-C3CC-A5340F33711F}"/>
+                    <a16:creationId xmlns:a16="http://schemas.microsoft.com/office/drawing/2014/main" id="{598FAB74-421E-F617-D06B-6D5B9FFC4FB7}"/>
                   </a:ext>
                 </a:extLst>
               </p:cNvPr>
-              <p:cNvSpPr txBox="1"/>
+              <p:cNvSpPr/>
               <p:nvPr/>
             </p:nvSpPr>
             <p:spPr>
               <a:xfrm>
-                <a:off x="8547006" y="1065865"/>
-                <a:ext cx="2791639" cy="738664"/>
+                <a:off x="4834069" y="3306995"/>
+                <a:ext cx="2134800" cy="514350"/>
               </a:xfrm>
               <a:prstGeom prst="rect">
                 <a:avLst/>
               </a:prstGeom>
-              <a:noFill/>
+              <a:solidFill>
+                <a:schemeClr val="accent2">
+                  <a:lumMod val="20000"/>
+                  <a:lumOff val="80000"/>
+                </a:schemeClr>
+              </a:solidFill>
             </p:spPr>
+            <p:style>
+              <a:lnRef idx="2">
+                <a:schemeClr val="accent1">
+                  <a:shade val="15000"/>
+                </a:schemeClr>
+              </a:lnRef>
+              <a:fillRef idx="1">
+                <a:schemeClr val="accent1"/>
+              </a:fillRef>
+              <a:effectRef idx="0">
+                <a:schemeClr val="accent1"/>
+              </a:effectRef>
+              <a:fontRef idx="minor">
+                <a:schemeClr val="lt1"/>
+              </a:fontRef>
+            </p:style>
             <p:txBody>
-              <a:bodyPr wrap="square" rtlCol="0">
-                <a:spAutoFit/>
-              </a:bodyPr>
+              <a:bodyPr rtlCol="0" anchor="ctr"/>
               <a:lstStyle/>
               <a:p>
+                <a:pPr algn="ctr"/>
                 <a:r>
-                  <a:rPr lang="de-DE" sz="1400" dirty="0"/>
-                  <a:t>Pass </a:t>
+                  <a:rPr lang="de-DE" dirty="0">
+                    <a:solidFill>
+                      <a:schemeClr val="tx1"/>
+                    </a:solidFill>
+                  </a:rPr>
+                  <a:t>Validation</a:t>
                 </a:r>
-                <a:r>
-                  <a:rPr lang="de-DE" sz="1400" dirty="0" err="1"/>
-                  <a:t>identified</a:t>
-                </a:r>
-                <a:r>
-                  <a:rPr lang="de-DE" sz="1400" dirty="0"/>
-                  <a:t> </a:t>
-                </a:r>
-                <a:r>
-                  <a:rPr lang="de-DE" sz="1400" dirty="0" err="1"/>
-                  <a:t>hyperparameters</a:t>
-                </a:r>
-                <a:r>
-                  <a:rPr lang="de-DE" sz="1400" dirty="0"/>
-                  <a:t> to </a:t>
-                </a:r>
-                <a:r>
-                  <a:rPr lang="de-DE" sz="1400" dirty="0" err="1"/>
-                  <a:t>training</a:t>
-                </a:r>
-                <a:r>
-                  <a:rPr lang="de-DE" sz="1400" dirty="0"/>
-                  <a:t> sample and </a:t>
-                </a:r>
-                <a:r>
-                  <a:rPr lang="de-DE" sz="1400" dirty="0" err="1"/>
-                  <a:t>re-identify</a:t>
-                </a:r>
-                <a:r>
-                  <a:rPr lang="de-DE" sz="1400" dirty="0"/>
-                  <a:t> </a:t>
-                </a:r>
-                <a:r>
-                  <a:rPr lang="de-DE" sz="1400" dirty="0" err="1"/>
-                  <a:t>threshold</a:t>
-                </a:r>
-                <a:endParaRPr lang="de-DE" sz="1400" dirty="0"/>
               </a:p>
             </p:txBody>
           </p:sp>
         </p:grpSp>
+        <p:sp>
+          <p:nvSpPr>
+            <p:cNvPr id="34" name="Textfeld 33">
+              <a:extLst>
+                <a:ext uri="{FF2B5EF4-FFF2-40B4-BE49-F238E27FC236}">
+                  <a16:creationId xmlns:a16="http://schemas.microsoft.com/office/drawing/2014/main" id="{DA318D28-C1BA-850F-C3CC-A5340F33711F}"/>
+                </a:ext>
+              </a:extLst>
+            </p:cNvPr>
+            <p:cNvSpPr txBox="1"/>
+            <p:nvPr/>
+          </p:nvSpPr>
+          <p:spPr>
+            <a:xfrm>
+              <a:off x="8547006" y="1065865"/>
+              <a:ext cx="2791639" cy="307777"/>
+            </a:xfrm>
+            <a:prstGeom prst="rect">
+              <a:avLst/>
+            </a:prstGeom>
+            <a:noFill/>
+          </p:spPr>
+          <p:txBody>
+            <a:bodyPr wrap="square" rtlCol="0">
+              <a:spAutoFit/>
+            </a:bodyPr>
+            <a:lstStyle/>
+            <a:p>
+              <a:endParaRPr lang="de-DE" sz="1400" dirty="0"/>
+            </a:p>
+          </p:txBody>
+        </p:sp>
+        <p:grpSp>
+          <p:nvGrpSpPr>
+            <p:cNvPr id="37" name="Gruppieren 36">
+              <a:extLst>
+                <a:ext uri="{FF2B5EF4-FFF2-40B4-BE49-F238E27FC236}">
+                  <a16:creationId xmlns:a16="http://schemas.microsoft.com/office/drawing/2014/main" id="{E8D8E4CB-0A21-E959-5947-DA6FBDD51399}"/>
+                </a:ext>
+              </a:extLst>
+            </p:cNvPr>
+            <p:cNvGrpSpPr/>
+            <p:nvPr/>
+          </p:nvGrpSpPr>
+          <p:grpSpPr>
+            <a:xfrm>
+              <a:off x="565915" y="3283858"/>
+              <a:ext cx="8015588" cy="514350"/>
+              <a:chOff x="568341" y="3306995"/>
+              <a:chExt cx="6400528" cy="514350"/>
+            </a:xfrm>
+            <a:effectLst>
+              <a:outerShdw blurRad="50800" dist="38100" dir="2700000" algn="tl" rotWithShape="0">
+                <a:prstClr val="black">
+                  <a:alpha val="40000"/>
+                </a:prstClr>
+              </a:outerShdw>
+            </a:effectLst>
+          </p:grpSpPr>
+          <p:sp>
+            <p:nvSpPr>
+              <p:cNvPr id="38" name="Rechteck 37">
+                <a:extLst>
+                  <a:ext uri="{FF2B5EF4-FFF2-40B4-BE49-F238E27FC236}">
+                    <a16:creationId xmlns:a16="http://schemas.microsoft.com/office/drawing/2014/main" id="{831443C3-C728-D546-C1CC-D0C2CD008257}"/>
+                  </a:ext>
+                </a:extLst>
+              </p:cNvPr>
+              <p:cNvSpPr/>
+              <p:nvPr/>
+            </p:nvSpPr>
+            <p:spPr>
+              <a:xfrm>
+                <a:off x="568341" y="3306995"/>
+                <a:ext cx="2134800" cy="514350"/>
+              </a:xfrm>
+              <a:prstGeom prst="rect">
+                <a:avLst/>
+              </a:prstGeom>
+              <a:solidFill>
+                <a:schemeClr val="accent1">
+                  <a:lumMod val="20000"/>
+                  <a:lumOff val="80000"/>
+                </a:schemeClr>
+              </a:solidFill>
+            </p:spPr>
+            <p:style>
+              <a:lnRef idx="2">
+                <a:schemeClr val="accent1">
+                  <a:shade val="15000"/>
+                </a:schemeClr>
+              </a:lnRef>
+              <a:fillRef idx="1">
+                <a:schemeClr val="accent1"/>
+              </a:fillRef>
+              <a:effectRef idx="0">
+                <a:schemeClr val="accent1"/>
+              </a:effectRef>
+              <a:fontRef idx="minor">
+                <a:schemeClr val="lt1"/>
+              </a:fontRef>
+            </p:style>
+            <p:txBody>
+              <a:bodyPr rtlCol="0" anchor="ctr"/>
+              <a:lstStyle/>
+              <a:p>
+                <a:pPr algn="ctr"/>
+                <a:r>
+                  <a:rPr lang="de-DE" dirty="0">
+                    <a:solidFill>
+                      <a:schemeClr val="tx1"/>
+                    </a:solidFill>
+                  </a:rPr>
+                  <a:t>Train</a:t>
+                </a:r>
+              </a:p>
+            </p:txBody>
+          </p:sp>
+          <p:sp>
+            <p:nvSpPr>
+              <p:cNvPr id="39" name="Rechteck 38">
+                <a:extLst>
+                  <a:ext uri="{FF2B5EF4-FFF2-40B4-BE49-F238E27FC236}">
+                    <a16:creationId xmlns:a16="http://schemas.microsoft.com/office/drawing/2014/main" id="{C821170C-7BD3-8864-A8C5-3E0B721FA6F0}"/>
+                  </a:ext>
+                </a:extLst>
+              </p:cNvPr>
+              <p:cNvSpPr/>
+              <p:nvPr/>
+            </p:nvSpPr>
+            <p:spPr>
+              <a:xfrm>
+                <a:off x="2699269" y="3306995"/>
+                <a:ext cx="2134800" cy="514350"/>
+              </a:xfrm>
+              <a:prstGeom prst="rect">
+                <a:avLst/>
+              </a:prstGeom>
+              <a:solidFill>
+                <a:schemeClr val="accent1">
+                  <a:lumMod val="20000"/>
+                  <a:lumOff val="80000"/>
+                </a:schemeClr>
+              </a:solidFill>
+            </p:spPr>
+            <p:style>
+              <a:lnRef idx="2">
+                <a:schemeClr val="accent1">
+                  <a:shade val="15000"/>
+                </a:schemeClr>
+              </a:lnRef>
+              <a:fillRef idx="1">
+                <a:schemeClr val="accent1"/>
+              </a:fillRef>
+              <a:effectRef idx="0">
+                <a:schemeClr val="accent1"/>
+              </a:effectRef>
+              <a:fontRef idx="minor">
+                <a:schemeClr val="lt1"/>
+              </a:fontRef>
+            </p:style>
+            <p:txBody>
+              <a:bodyPr rtlCol="0" anchor="ctr"/>
+              <a:lstStyle/>
+              <a:p>
+                <a:pPr algn="ctr"/>
+                <a:r>
+                  <a:rPr lang="de-DE" dirty="0">
+                    <a:solidFill>
+                      <a:schemeClr val="tx1"/>
+                    </a:solidFill>
+                  </a:rPr>
+                  <a:t>Train</a:t>
+                </a:r>
+              </a:p>
+            </p:txBody>
+          </p:sp>
+          <p:sp>
+            <p:nvSpPr>
+              <p:cNvPr id="40" name="Rechteck 39">
+                <a:extLst>
+                  <a:ext uri="{FF2B5EF4-FFF2-40B4-BE49-F238E27FC236}">
+                    <a16:creationId xmlns:a16="http://schemas.microsoft.com/office/drawing/2014/main" id="{395690B1-1CA2-93D8-915A-513A65F66EC1}"/>
+                  </a:ext>
+                </a:extLst>
+              </p:cNvPr>
+              <p:cNvSpPr/>
+              <p:nvPr/>
+            </p:nvSpPr>
+            <p:spPr>
+              <a:xfrm>
+                <a:off x="4834069" y="3306995"/>
+                <a:ext cx="2134800" cy="514350"/>
+              </a:xfrm>
+              <a:prstGeom prst="rect">
+                <a:avLst/>
+              </a:prstGeom>
+              <a:solidFill>
+                <a:schemeClr val="accent2">
+                  <a:lumMod val="20000"/>
+                  <a:lumOff val="80000"/>
+                </a:schemeClr>
+              </a:solidFill>
+            </p:spPr>
+            <p:style>
+              <a:lnRef idx="2">
+                <a:schemeClr val="accent1">
+                  <a:shade val="15000"/>
+                </a:schemeClr>
+              </a:lnRef>
+              <a:fillRef idx="1">
+                <a:schemeClr val="accent1"/>
+              </a:fillRef>
+              <a:effectRef idx="0">
+                <a:schemeClr val="accent1"/>
+              </a:effectRef>
+              <a:fontRef idx="minor">
+                <a:schemeClr val="lt1"/>
+              </a:fontRef>
+            </p:style>
+            <p:txBody>
+              <a:bodyPr rtlCol="0" anchor="ctr"/>
+              <a:lstStyle/>
+              <a:p>
+                <a:pPr algn="ctr"/>
+                <a:r>
+                  <a:rPr lang="de-DE" dirty="0">
+                    <a:solidFill>
+                      <a:schemeClr val="tx1"/>
+                    </a:solidFill>
+                  </a:rPr>
+                  <a:t>Validation</a:t>
+                </a:r>
+              </a:p>
+            </p:txBody>
+          </p:sp>
+        </p:grpSp>
+        <p:sp>
+          <p:nvSpPr>
+            <p:cNvPr id="41" name="Textfeld 40">
+              <a:extLst>
+                <a:ext uri="{FF2B5EF4-FFF2-40B4-BE49-F238E27FC236}">
+                  <a16:creationId xmlns:a16="http://schemas.microsoft.com/office/drawing/2014/main" id="{69091A03-565F-4943-A1A2-C0583A795041}"/>
+                </a:ext>
+              </a:extLst>
+            </p:cNvPr>
+            <p:cNvSpPr txBox="1"/>
+            <p:nvPr/>
+          </p:nvSpPr>
+          <p:spPr>
+            <a:xfrm>
+              <a:off x="9129009" y="2395098"/>
+              <a:ext cx="1876969" cy="738664"/>
+            </a:xfrm>
+            <a:prstGeom prst="rect">
+              <a:avLst/>
+            </a:prstGeom>
+            <a:noFill/>
+          </p:spPr>
+          <p:txBody>
+            <a:bodyPr wrap="square" rtlCol="0">
+              <a:spAutoFit/>
+            </a:bodyPr>
+            <a:lstStyle/>
+            <a:p>
+              <a:r>
+                <a:rPr lang="de-DE" sz="1400" dirty="0"/>
+                <a:t>Reuse </a:t>
+              </a:r>
+              <a:r>
+                <a:rPr lang="de-DE" sz="1400" dirty="0" err="1"/>
+                <a:t>training</a:t>
+              </a:r>
+              <a:r>
+                <a:rPr lang="de-DE" sz="1400" dirty="0"/>
+                <a:t> </a:t>
+              </a:r>
+              <a:r>
+                <a:rPr lang="de-DE" sz="1400" dirty="0" err="1"/>
+                <a:t>set</a:t>
+              </a:r>
+              <a:r>
+                <a:rPr lang="de-DE" sz="1400" dirty="0"/>
+                <a:t> with </a:t>
+              </a:r>
+              <a:r>
+                <a:rPr lang="de-DE" sz="1400" dirty="0" err="1"/>
+                <a:t>identified</a:t>
+              </a:r>
+              <a:r>
+                <a:rPr lang="de-DE" sz="1400" dirty="0"/>
+                <a:t> </a:t>
+              </a:r>
+              <a:r>
+                <a:rPr lang="de-DE" sz="1400" dirty="0" err="1"/>
+                <a:t>hyperparameters</a:t>
+              </a:r>
+              <a:endParaRPr lang="de-DE" sz="1400" dirty="0"/>
+            </a:p>
+          </p:txBody>
+        </p:sp>
+        <p:sp>
+          <p:nvSpPr>
+            <p:cNvPr id="42" name="Bogen 41">
+              <a:extLst>
+                <a:ext uri="{FF2B5EF4-FFF2-40B4-BE49-F238E27FC236}">
+                  <a16:creationId xmlns:a16="http://schemas.microsoft.com/office/drawing/2014/main" id="{CAC9B9BA-3914-D1D4-7961-0C9D7D994F2B}"/>
+                </a:ext>
+              </a:extLst>
+            </p:cNvPr>
+            <p:cNvSpPr/>
+            <p:nvPr/>
+          </p:nvSpPr>
+          <p:spPr>
+            <a:xfrm rot="2771285">
+              <a:off x="6934651" y="1717443"/>
+              <a:ext cx="2272275" cy="2093975"/>
+            </a:xfrm>
+            <a:prstGeom prst="arc">
+              <a:avLst/>
+            </a:prstGeom>
+            <a:ln>
+              <a:tailEnd type="triangle" w="lg" len="med"/>
+            </a:ln>
+          </p:spPr>
+          <p:style>
+            <a:lnRef idx="2">
+              <a:schemeClr val="dk1"/>
+            </a:lnRef>
+            <a:fillRef idx="0">
+              <a:schemeClr val="dk1"/>
+            </a:fillRef>
+            <a:effectRef idx="1">
+              <a:schemeClr val="dk1"/>
+            </a:effectRef>
+            <a:fontRef idx="minor">
+              <a:schemeClr val="tx1"/>
+            </a:fontRef>
+          </p:style>
+          <p:txBody>
+            <a:bodyPr rtlCol="0" anchor="ctr"/>
+            <a:lstStyle/>
+            <a:p>
+              <a:pPr algn="ctr"/>
+              <a:endParaRPr lang="de-DE"/>
+            </a:p>
+          </p:txBody>
+        </p:sp>
+        <p:sp>
+          <p:nvSpPr>
+            <p:cNvPr id="43" name="Bogen 42">
+              <a:extLst>
+                <a:ext uri="{FF2B5EF4-FFF2-40B4-BE49-F238E27FC236}">
+                  <a16:creationId xmlns:a16="http://schemas.microsoft.com/office/drawing/2014/main" id="{3579F936-032E-FF02-05C5-E4A1684FCBF0}"/>
+                </a:ext>
+              </a:extLst>
+            </p:cNvPr>
+            <p:cNvSpPr/>
+            <p:nvPr/>
+          </p:nvSpPr>
+          <p:spPr>
+            <a:xfrm rot="21066399" flipV="1">
+              <a:off x="7657118" y="1307015"/>
+              <a:ext cx="3424659" cy="2683903"/>
+            </a:xfrm>
+            <a:prstGeom prst="arc">
+              <a:avLst>
+                <a:gd name="adj1" fmla="val 15857762"/>
+                <a:gd name="adj2" fmla="val 4098216"/>
+              </a:avLst>
+            </a:prstGeom>
+            <a:ln>
+              <a:tailEnd type="triangle" w="lg" len="med"/>
+            </a:ln>
+          </p:spPr>
+          <p:style>
+            <a:lnRef idx="2">
+              <a:schemeClr val="dk1"/>
+            </a:lnRef>
+            <a:fillRef idx="0">
+              <a:schemeClr val="dk1"/>
+            </a:fillRef>
+            <a:effectRef idx="1">
+              <a:schemeClr val="dk1"/>
+            </a:effectRef>
+            <a:fontRef idx="minor">
+              <a:schemeClr val="tx1"/>
+            </a:fontRef>
+          </p:style>
+          <p:txBody>
+            <a:bodyPr rtlCol="0" anchor="ctr"/>
+            <a:lstStyle/>
+            <a:p>
+              <a:pPr algn="ctr"/>
+              <a:endParaRPr lang="de-DE"/>
+            </a:p>
+          </p:txBody>
+        </p:sp>
+        <p:sp>
+          <p:nvSpPr>
+            <p:cNvPr id="44" name="Textfeld 43">
+              <a:extLst>
+                <a:ext uri="{FF2B5EF4-FFF2-40B4-BE49-F238E27FC236}">
+                  <a16:creationId xmlns:a16="http://schemas.microsoft.com/office/drawing/2014/main" id="{207F10EE-49DC-DFF5-604E-C9B96E149CA2}"/>
+                </a:ext>
+              </a:extLst>
+            </p:cNvPr>
+            <p:cNvSpPr txBox="1"/>
+            <p:nvPr/>
+          </p:nvSpPr>
+          <p:spPr>
+            <a:xfrm>
+              <a:off x="8070788" y="4096289"/>
+              <a:ext cx="2962994" cy="523220"/>
+            </a:xfrm>
+            <a:prstGeom prst="rect">
+              <a:avLst/>
+            </a:prstGeom>
+            <a:noFill/>
+          </p:spPr>
+          <p:txBody>
+            <a:bodyPr wrap="square" rtlCol="0">
+              <a:spAutoFit/>
+            </a:bodyPr>
+            <a:lstStyle/>
+            <a:p>
+              <a:r>
+                <a:rPr lang="de-DE" sz="1400" dirty="0"/>
+                <a:t>Refit </a:t>
+              </a:r>
+              <a:r>
+                <a:rPr lang="de-DE" sz="1400" dirty="0" err="1"/>
+                <a:t>selected</a:t>
+              </a:r>
+              <a:r>
+                <a:rPr lang="de-DE" sz="1400" dirty="0"/>
+                <a:t> </a:t>
+              </a:r>
+              <a:r>
+                <a:rPr lang="de-DE" sz="1400" dirty="0" err="1"/>
+                <a:t>model</a:t>
+              </a:r>
+              <a:r>
+                <a:rPr lang="de-DE" sz="1400" dirty="0"/>
+                <a:t> with </a:t>
+              </a:r>
+              <a:r>
+                <a:rPr lang="de-DE" sz="1400" dirty="0" err="1"/>
+                <a:t>identified</a:t>
+              </a:r>
+              <a:r>
+                <a:rPr lang="de-DE" sz="1400" dirty="0"/>
+                <a:t> </a:t>
+              </a:r>
+              <a:r>
+                <a:rPr lang="de-DE" sz="1400" dirty="0" err="1"/>
+                <a:t>threshold</a:t>
+              </a:r>
+              <a:r>
+                <a:rPr lang="de-DE" sz="1400" dirty="0"/>
+                <a:t> to </a:t>
+              </a:r>
+              <a:r>
+                <a:rPr lang="de-DE" sz="1400" dirty="0" err="1"/>
+                <a:t>training</a:t>
+              </a:r>
+              <a:r>
+                <a:rPr lang="de-DE" sz="1400" dirty="0"/>
+                <a:t> </a:t>
+              </a:r>
+              <a:r>
+                <a:rPr lang="de-DE" sz="1400" dirty="0" err="1"/>
+                <a:t>data</a:t>
+              </a:r>
+              <a:endParaRPr lang="de-DE" sz="1400" dirty="0"/>
+            </a:p>
+          </p:txBody>
+        </p:sp>
       </p:grpSp>
     </p:spTree>
     <p:extLst>

</xml_diff>